<commit_message>
Add oval bowls, jet position and a detailed model description
- model.js: wall film traced on an oval wall surface (constant area per depth), elliptic pool inertia and ovality swirl loss
- app.js: ovality and jet position sliders, oval top view, sweep axes for both
- method.html: full description of equations, numerics, coefficients, calibration with PreonLab and comparison with other approaches
- index.html: link to the model description at the bottom
- media, slides: recaptured with the updated model

Co-Authored-By: Claude Opus 5.5 <noreply@anthropic.com>
Claude-Session: https://claude.ai/code/session_01Ts1CDiRcVEqGThv3u6a6um
</commit_message>
<xml_diff>
--- a/slides/jet-flush-model.pptx
+++ b/slides/jet-flush-model.pptx
@@ -107,7 +107,7 @@
   <p:extLst>
     <p:ext uri="{521415D9-36F7-43E2-AB2F-B90AF26B5E84}">
       <p14:sectionLst xmlns:p14="http://schemas.microsoft.com/office/powerpoint/2010/main">
-        <p14:section name="Simulator" id="{f5213436-44f1-4ff5-21d6-7dd3161a1eb5}">
+        <p14:section name="Simulator" id="{9e88b55f-5cc8-0a41-91e8-46605ccd8002}">
           <p14:sldIdLst>
             <p14:sldId id="256"/>
           </p14:sldIdLst>
@@ -1102,7 +1102,7 @@
                   <a:schemeClr val="accent1"/>
                 </a:solidFill>
               </a:rPr>
-              <a:t>87 %</a:t>
+              <a:t>88 %</a:t>
             </a:r>
             <a:endParaRPr lang="en-US" sz="4400" dirty="0"/>
           </a:p>

</xml_diff>